<commit_message>
Clarify decision gates and finite-shot evidence
</commit_message>
<xml_diff>
--- a/deliverables/Quanova_Photonic_QML_Interview_Case_Study_20260912.pptx
+++ b/deliverables/Quanova_Photonic_QML_Interview_Case_Study_20260912.pptx
@@ -415,7 +415,7 @@
             <a:pPr/>
             <a:r>
               <a:rPr lang="en-US" dirty="0"/>
-              <a:t>My recommendation is conditional. Few-label defect inspection fits a useful Quandela simulator-to-hardware study, and the pilot shows that the simulation workflow is executable. It has not demonstrated practical or hardware advantage. I continue only if Pass A at forty-eight labels or Pass B for twofold label efficiency holds. The shot and acceptance constraints belong only to Pass B. If neither passes, or Q1 loses to RFF-15 and ELM-15 on at least four folds, I report simulation feasibility without utility and stop before spending QPU time. Thank you.</a:t>
+              <a:t>My recommendation is conditional. Few-label defect inspection fits a useful Quandela simulator-to-hardware study, and the pilot shows that the simulation workflow is executable. It has not demonstrated practical or hardware advantage. B4 is the PCA-five RBF-SVM reference. I continue only if Pass A at forty-eight labels or Pass B for twofold label efficiency holds. The shot and acceptance constraints belong only to Pass B. If neither passes, or Q1 loses to RFF-15 and ELM-15 on at least four folds, I report simulation feasibility without utility and stop before spending QPU time. Thank you.</a:t>
             </a:r>
           </a:p>
         </p:txBody>
@@ -595,7 +595,7 @@
             <a:pPr/>
             <a:r>
               <a:rPr lang="en-US" dirty="0"/>
-              <a:t>From the same PCA-five input, can Q1 beat matched fifteen-dimensional controls and approach PCA-five RBF-SVM? RFF means random Fourier features; ELM means extreme learning machine. I preregister two pass routes. Pass A: at forty-eight labels per class, Q1 is within 0.02 macro-F1 of RBF-SVM on at least four of five folds. Pass B: Q1 at twenty-four labels reaches the forty-eight-label RBF-SVM within 0.02 on four folds, using at most two thousand shots per image and acceptance of at least 0.70. I stop if neither passes, or Q1 loses to both RFF-15 and ELM-15 on four folds. These gates define the proposed project; the pilot is already complete.</a:t>
+              <a:t>From the same PCA-five input, can Q1 beat matched fifteen-dimensional controls and approach B4, the PCA-five RBF-SVM? RFF means random Fourier features; ELM means extreme learning machine. I preregister two pass routes. Pass A: at forty-eight labels per class, Q1 is within 0.02 macro-F1 of B4 on at least four of five folds. Pass B: Q1 at twenty-four labels reaches B4 at forty-eight labels within 0.02 on four folds, using at most two thousand shots per image and acceptance of at least 0.70. I stop if neither passes, or Q1 loses to both RFF-15 and ELM-15 on four folds. These gates define the proposed project; the pilot is already complete.</a:t>
             </a:r>
           </a:p>
         </p:txBody>
@@ -775,7 +775,7 @@
             <a:pPr/>
             <a:r>
               <a:rPr lang="en-US" dirty="0"/>
-              <a:t>PCA-five costs the linear baseline about 0.07 to 0.10 macro-F1, so important information is lost before the nonlinear comparison. Within the compressed setting, Q1 beats the locked RFF-15 comparator by 0.22 to 0.31. It still trails ELM by about 0.02 to 0.04 and PCA-five RBF-SVM by about 0.05 to 0.06. I would therefore vary representation size and circuit design separately rather than attributing the whole gap to photonics. Before proposing hardware, I also tested whether sampling is stable.</a:t>
+              <a:t>PCA-five costs the linear baseline about 0.07 to 0.10 macro-F1, accounting for most of the gap to the full representation. Within the compressed setting, Q1 beats the locked RFF-15 comparator by 0.22 to 0.31. It still trails ELM by about 0.02 to 0.04 and PCA-five RBF-SVM by about 0.05 to 0.06, so map choice explains the remaining shortfall. I would therefore vary representation size and circuit design separately. Before proposing hardware, I also tested whether sampling is stable.</a:t>
             </a:r>
           </a:p>
         </p:txBody>
@@ -835,7 +835,7 @@
             <a:pPr/>
             <a:r>
               <a:rPr lang="en-US" dirty="0"/>
-              <a:t>Macro-F1 remains near 0.77 from five hundred to eight thousand launched shots. Each level contains three map seeds times five sampling seeds; all forty-five evaluations share one outer test fold. Acceptance stays near 0.754 with no zero-acceptance failures. More shots do not recover accuracy, so sampling noise is not the main limitation in this range. Photon loss, phase drift, distinguishability, detector effects, and noise-aware training remain untested. These results define the current evidence boundary.</a:t>
+              <a:t>At twenty-four labels per class on outer fold zero, Q1 stays near 0.77 from five hundred to eight thousand shots. Each level has three map seeds by five sampling seeds; all forty-five evaluations share that fold. Acceptance is near 0.754 with no failures. Increasing shots does not recover accuracy, so sampling noise is not the main limitation in this range. Loss, drift, distinguishability, detector effects, and noise-aware training remain untested. These results define the evidence boundary.</a:t>
             </a:r>
           </a:p>
         </p:txBody>
@@ -3088,9 +3088,9 @@
         <p:grpSpPr>
           <a:xfrm>
             <a:off x="6598044" y="1562100"/>
-            <a:ext cx="5025466" cy="3905250"/>
+            <a:ext cx="5015711" cy="3905250"/>
             <a:chOff x="6598044" y="1562100"/>
-            <a:chExt cx="5025466" cy="3905250"/>
+            <a:chExt cx="5015711" cy="3905250"/>
           </a:xfrm>
         </p:grpSpPr>
         <p:sp>
@@ -3123,26 +3123,26 @@
           </p:nvSpPr>
           <p:spPr>
             <a:xfrm>
-              <a:off x="6889242" y="1759268"/>
-              <a:ext cx="1667043" cy="264033"/>
-            </a:xfrm>
-            <a:prstGeom prst="rect">
-              <a:avLst/>
-            </a:prstGeom>
-            <a:noFill/>
-            <a:ln>
-              <a:noFill/>
-            </a:ln>
-          </p:spPr>
-          <p:txBody>
-            <a:bodyPr wrap="none" lIns="0" tIns="0" rIns="0" bIns="0" anchor="t" anchorCtr="0">
-              <a:spAutoFit/>
-            </a:bodyPr>
-            <a:lstStyle/>
-            <a:p>
-              <a:pPr algn="l"/>
-              <a:r>
-                <a:rPr lang="en-US" sz="1350" b="1" dirty="0">
+              <a:off x="6890004" y="1775460"/>
+              <a:ext cx="3363651" cy="234696"/>
+            </a:xfrm>
+            <a:prstGeom prst="rect">
+              <a:avLst/>
+            </a:prstGeom>
+            <a:noFill/>
+            <a:ln>
+              <a:noFill/>
+            </a:ln>
+          </p:spPr>
+          <p:txBody>
+            <a:bodyPr wrap="none" lIns="0" tIns="0" rIns="0" bIns="0" anchor="t" anchorCtr="0">
+              <a:spAutoFit/>
+            </a:bodyPr>
+            <a:lstStyle/>
+            <a:p>
+              <a:pPr algn="l"/>
+              <a:r>
+                <a:rPr lang="en-US" sz="1200" b="1" dirty="0">
                   <a:solidFill>
                     <a:srgbClr val="B9D0C7"/>
                   </a:solidFill>
@@ -3150,7 +3150,7 @@
                   <a:ea typeface="+mn-ea"/>
                   <a:cs typeface="+mn-cs"/>
                 </a:rPr>
-                <a:t>CONTINUE ONLY IF</a:t>
+                <a:t>CONTINUE ONLY IF · B4 = PCA-5 RBF-SVM</a:t>
               </a:r>
             </a:p>
           </p:txBody>
@@ -3164,7 +3164,7 @@
           <p:spPr>
             <a:xfrm>
               <a:off x="6888480" y="2076450"/>
-              <a:ext cx="4735030" cy="293370"/>
+              <a:ext cx="3932530" cy="293370"/>
             </a:xfrm>
             <a:prstGeom prst="rect">
               <a:avLst/>
@@ -3190,7 +3190,7 @@
                   <a:ea typeface="+mj-ea"/>
                   <a:cs typeface="+mj-cs"/>
                 </a:rPr>
-                <a:t>PASS A · Q1@48 ≥ RBF-SVM@48 − 0.02</a:t>
+                <a:t>PASS A · Q1@48 ≥ B4@48 − 0.02</a:t>
               </a:r>
             </a:p>
           </p:txBody>
@@ -3244,7 +3244,7 @@
           <p:spPr>
             <a:xfrm>
               <a:off x="6888480" y="2619375"/>
-              <a:ext cx="4735030" cy="293370"/>
+              <a:ext cx="3932530" cy="293370"/>
             </a:xfrm>
             <a:prstGeom prst="rect">
               <a:avLst/>
@@ -3270,7 +3270,7 @@
                   <a:ea typeface="+mj-ea"/>
                   <a:cs typeface="+mj-cs"/>
                 </a:rPr>
-                <a:t>PASS B · Q1@24 ≥ RBF-SVM@48 − 0.02</a:t>
+                <a:t>PASS B · Q1@24 ≥ B4@48 − 0.02</a:t>
               </a:r>
             </a:p>
           </p:txBody>
@@ -8203,9 +8203,9 @@
         <p:grpSpPr>
           <a:xfrm>
             <a:off x="7467600" y="2647950"/>
-            <a:ext cx="4339273" cy="2975134"/>
+            <a:ext cx="4114800" cy="2975134"/>
             <a:chOff x="7467600" y="2647950"/>
-            <a:chExt cx="4339273" cy="2975134"/>
+            <a:chExt cx="4114800" cy="2975134"/>
           </a:xfrm>
         </p:grpSpPr>
         <p:sp>
@@ -8279,7 +8279,7 @@
           <p:spPr>
             <a:xfrm>
               <a:off x="7687437" y="3080861"/>
-              <a:ext cx="4119436" cy="337376"/>
+              <a:ext cx="3199236" cy="337376"/>
             </a:xfrm>
             <a:prstGeom prst="rect">
               <a:avLst/>
@@ -8305,7 +8305,7 @@
                   <a:ea typeface="+mj-ea"/>
                   <a:cs typeface="+mj-cs"/>
                 </a:rPr>
-                <a:t>Q1@48 ≥ RBF-SVM@48 − 0.02</a:t>
+                <a:t>Q1@48 ≥ B4@48 − 0.02</a:t>
               </a:r>
             </a:p>
           </p:txBody>
@@ -8421,7 +8421,7 @@
           <p:spPr>
             <a:xfrm>
               <a:off x="7687818" y="4193858"/>
-              <a:ext cx="3951736" cy="322707"/>
+              <a:ext cx="3068985" cy="322707"/>
             </a:xfrm>
             <a:prstGeom prst="rect">
               <a:avLst/>
@@ -8447,7 +8447,7 @@
                   <a:ea typeface="+mj-ea"/>
                   <a:cs typeface="+mj-cs"/>
                 </a:rPr>
-                <a:t>Q1@24 ≥ RBF-SVM@48 − 0.02</a:t>
+                <a:t>Q1@24 ≥ B4@48 − 0.02</a:t>
               </a:r>
             </a:p>
           </p:txBody>
@@ -8644,9 +8644,9 @@
         <p:grpSpPr>
           <a:xfrm>
             <a:off x="603885" y="5926931"/>
-            <a:ext cx="11046145" cy="420053"/>
+            <a:ext cx="10597215" cy="420053"/>
             <a:chOff x="603885" y="5926931"/>
-            <a:chExt cx="11046145" cy="420053"/>
+            <a:chExt cx="10597215" cy="420053"/>
           </a:xfrm>
         </p:grpSpPr>
         <p:sp>
@@ -8698,7 +8698,7 @@
           <p:spPr>
             <a:xfrm>
               <a:off x="603885" y="6126956"/>
-              <a:ext cx="11046145" cy="220028"/>
+              <a:ext cx="10597215" cy="220028"/>
             </a:xfrm>
             <a:prstGeom prst="rect">
               <a:avLst/>
@@ -8724,7 +8724,7 @@
                   <a:ea typeface="+mn-ea"/>
                   <a:cs typeface="+mn-cs"/>
                 </a:rPr>
-                <a:t>RBF-SVM = radial-basis-function support vector machine. Resource value is pre-specified as label efficiency under shot and acceptance constraints.</a:t>
+                <a:t>B4 = PCA-5 radial-basis-function support vector machine (RBF-SVM); resource value = label efficiency under shot and acceptance constraints.</a:t>
               </a:r>
             </a:p>
           </p:txBody>
@@ -12290,10 +12290,10 @@
         </p:nvGrpSpPr>
         <p:grpSpPr>
           <a:xfrm>
-            <a:off x="595122" y="482918"/>
-            <a:ext cx="11637032" cy="900303"/>
-            <a:chOff x="595122" y="482918"/>
-            <a:chExt cx="11637032" cy="900303"/>
+            <a:off x="596646" y="482918"/>
+            <a:ext cx="10942045" cy="874013"/>
+            <a:chOff x="596646" y="482918"/>
+            <a:chExt cx="10942045" cy="874013"/>
           </a:xfrm>
         </p:grpSpPr>
         <p:sp>
@@ -12344,26 +12344,26 @@
           </p:nvSpPr>
           <p:spPr>
             <a:xfrm>
-              <a:off x="595122" y="825818"/>
-              <a:ext cx="11637032" cy="557403"/>
-            </a:xfrm>
-            <a:prstGeom prst="rect">
-              <a:avLst/>
-            </a:prstGeom>
-            <a:noFill/>
-            <a:ln>
-              <a:noFill/>
-            </a:ln>
-          </p:spPr>
-          <p:txBody>
-            <a:bodyPr wrap="none" lIns="0" tIns="0" rIns="0" bIns="0" anchor="t" anchorCtr="0">
-              <a:spAutoFit/>
-            </a:bodyPr>
-            <a:lstStyle/>
-            <a:p>
-              <a:pPr algn="l"/>
-              <a:r>
-                <a:rPr lang="en-US" sz="2850" b="1" dirty="0">
+              <a:off x="596646" y="858202"/>
+              <a:ext cx="10942045" cy="498729"/>
+            </a:xfrm>
+            <a:prstGeom prst="rect">
+              <a:avLst/>
+            </a:prstGeom>
+            <a:noFill/>
+            <a:ln>
+              <a:noFill/>
+            </a:ln>
+          </p:spPr>
+          <p:txBody>
+            <a:bodyPr wrap="none" lIns="0" tIns="0" rIns="0" bIns="0" anchor="t" anchorCtr="0">
+              <a:spAutoFit/>
+            </a:bodyPr>
+            <a:lstStyle/>
+            <a:p>
+              <a:pPr algn="l"/>
+              <a:r>
+                <a:rPr lang="en-US" sz="2550" b="1" dirty="0">
                   <a:solidFill>
                     <a:schemeClr val="accent1"/>
                   </a:solidFill>
@@ -12371,7 +12371,7 @@
                   <a:ea typeface="+mj-ea"/>
                   <a:cs typeface="+mj-cs"/>
                 </a:rPr>
-                <a:t>Compression—not photonics alone—explains the shortfall</a:t>
+                <a:t>PCA-5 explains most of the gap; the map explains the rest</a:t>
               </a:r>
             </a:p>
           </p:txBody>
@@ -13261,7 +13261,7 @@
       </p:grpSp>
       <p:grpSp>
         <p:nvGrpSpPr>
-          <p:cNvPr id="12" name="Group 12"/>
+          <p:cNvPr id="14" name="Group 14"/>
           <p:cNvGrpSpPr/>
           <p:nvPr/>
         </p:nvGrpSpPr>
@@ -13327,6 +13327,70 @@
           </p:nvSpPr>
           <p:spPr>
             <a:xfrm>
+              <a:off x="895350" y="1752600"/>
+              <a:ext cx="2838450" cy="257175"/>
+            </a:xfrm>
+            <a:prstGeom prst="rect">
+              <a:avLst/>
+            </a:prstGeom>
+            <a:solidFill>
+              <a:srgbClr val="FFFFFF">
+                <a:alpha val="94000"/>
+              </a:srgbClr>
+            </a:solidFill>
+            <a:ln>
+              <a:noFill/>
+            </a:ln>
+          </p:spPr>
+        </p:sp>
+        <p:sp>
+          <p:nvSpPr>
+            <p:cNvPr id="9" name="TextBox 9"/>
+            <p:cNvSpPr txBox="1"/>
+            <p:nvPr/>
+          </p:nvSpPr>
+          <p:spPr>
+            <a:xfrm>
+              <a:off x="966216" y="1820228"/>
+              <a:ext cx="2943195" cy="205359"/>
+            </a:xfrm>
+            <a:prstGeom prst="rect">
+              <a:avLst/>
+            </a:prstGeom>
+            <a:noFill/>
+            <a:ln>
+              <a:noFill/>
+            </a:ln>
+          </p:spPr>
+          <p:txBody>
+            <a:bodyPr wrap="none" lIns="0" tIns="0" rIns="0" bIns="0" anchor="t" anchorCtr="0">
+              <a:spAutoFit/>
+            </a:bodyPr>
+            <a:lstStyle/>
+            <a:p>
+              <a:pPr algn="l"/>
+              <a:r>
+                <a:rPr lang="en-US" sz="1050" b="1" dirty="0">
+                  <a:solidFill>
+                    <a:schemeClr val="accent1"/>
+                  </a:solidFill>
+                  <a:latin typeface="+mn-lt"/>
+                  <a:ea typeface="+mn-ea"/>
+                  <a:cs typeface="+mn-cs"/>
+                </a:rPr>
+                <a:t>Q1 · 24 LABELS / CLASS · OUTER FOLD 0</a:t>
+              </a:r>
+            </a:p>
+          </p:txBody>
+        </p:sp>
+        <p:sp>
+          <p:nvSpPr>
+            <p:cNvPr id="10" name="Rectangle 10"/>
+            <p:cNvSpPr/>
+            <p:nvPr/>
+          </p:nvSpPr>
+          <p:spPr>
+            <a:xfrm>
               <a:off x="4762500" y="2228850"/>
               <a:ext cx="1200150" cy="238125"/>
             </a:xfrm>
@@ -13345,7 +13409,7 @@
         </p:sp>
         <p:sp>
           <p:nvSpPr>
-            <p:cNvPr id="9" name="TextBox 9"/>
+            <p:cNvPr id="11" name="TextBox 11"/>
             <p:cNvSpPr txBox="1"/>
             <p:nvPr/>
           </p:nvSpPr>
@@ -13385,7 +13449,7 @@
         </p:sp>
         <p:sp>
           <p:nvSpPr>
-            <p:cNvPr id="10" name="Rectangle 10"/>
+            <p:cNvPr id="12" name="Rectangle 12"/>
             <p:cNvSpPr/>
             <p:nvPr/>
           </p:nvSpPr>
@@ -13409,7 +13473,7 @@
         </p:sp>
         <p:sp>
           <p:nvSpPr>
-            <p:cNvPr id="11" name="TextBox 11"/>
+            <p:cNvPr id="13" name="TextBox 13"/>
             <p:cNvSpPr txBox="1"/>
             <p:nvPr/>
           </p:nvSpPr>
@@ -13450,7 +13514,7 @@
       </p:grpSp>
       <p:grpSp>
         <p:nvGrpSpPr>
-          <p:cNvPr id="29" name="Group 29"/>
+          <p:cNvPr id="31" name="Group 31"/>
           <p:cNvGrpSpPr/>
           <p:nvPr/>
         </p:nvGrpSpPr>
@@ -13464,7 +13528,7 @@
         </p:grpSpPr>
         <p:sp>
           <p:nvSpPr>
-            <p:cNvPr id="13" name="TextBox 13"/>
+            <p:cNvPr id="15" name="TextBox 15"/>
             <p:cNvSpPr txBox="1"/>
             <p:nvPr/>
           </p:nvSpPr>
@@ -13504,7 +13568,7 @@
         </p:sp>
         <p:sp>
           <p:nvSpPr>
-            <p:cNvPr id="14" name="TextBox 14"/>
+            <p:cNvPr id="16" name="TextBox 16"/>
             <p:cNvSpPr txBox="1"/>
             <p:nvPr/>
           </p:nvSpPr>
@@ -13544,7 +13608,7 @@
         </p:sp>
         <p:sp>
           <p:nvSpPr>
-            <p:cNvPr id="15" name="TextBox 15"/>
+            <p:cNvPr id="17" name="TextBox 17"/>
             <p:cNvSpPr txBox="1"/>
             <p:nvPr/>
           </p:nvSpPr>
@@ -13584,7 +13648,7 @@
         </p:sp>
         <p:sp>
           <p:nvSpPr>
-            <p:cNvPr id="16" name="TextBox 16"/>
+            <p:cNvPr id="18" name="TextBox 18"/>
             <p:cNvSpPr txBox="1"/>
             <p:nvPr/>
           </p:nvSpPr>
@@ -13624,7 +13688,7 @@
         </p:sp>
         <p:sp>
           <p:nvSpPr>
-            <p:cNvPr id="17" name="TextBox 17"/>
+            <p:cNvPr id="19" name="TextBox 19"/>
             <p:cNvSpPr txBox="1"/>
             <p:nvPr/>
           </p:nvSpPr>
@@ -13664,7 +13728,7 @@
         </p:sp>
         <p:sp>
           <p:nvSpPr>
-            <p:cNvPr id="18" name="TextBox 18"/>
+            <p:cNvPr id="20" name="TextBox 20"/>
             <p:cNvSpPr txBox="1"/>
             <p:nvPr/>
           </p:nvSpPr>
@@ -13704,7 +13768,7 @@
         </p:sp>
         <p:sp>
           <p:nvSpPr>
-            <p:cNvPr id="19" name="TextBox 19"/>
+            <p:cNvPr id="21" name="TextBox 21"/>
             <p:cNvSpPr txBox="1"/>
             <p:nvPr/>
           </p:nvSpPr>
@@ -13744,7 +13808,7 @@
         </p:sp>
         <p:sp>
           <p:nvSpPr>
-            <p:cNvPr id="20" name="Rectangle 20"/>
+            <p:cNvPr id="22" name="Rectangle 22"/>
             <p:cNvSpPr/>
             <p:nvPr/>
           </p:nvSpPr>
@@ -13766,7 +13830,7 @@
         </p:sp>
         <p:sp>
           <p:nvSpPr>
-            <p:cNvPr id="21" name="TextBox 21"/>
+            <p:cNvPr id="23" name="TextBox 23"/>
             <p:cNvSpPr txBox="1"/>
             <p:nvPr/>
           </p:nvSpPr>
@@ -13806,7 +13870,7 @@
         </p:sp>
         <p:sp>
           <p:nvSpPr>
-            <p:cNvPr id="22" name="TextBox 22"/>
+            <p:cNvPr id="24" name="TextBox 24"/>
             <p:cNvSpPr txBox="1"/>
             <p:nvPr/>
           </p:nvSpPr>
@@ -13846,7 +13910,7 @@
         </p:sp>
         <p:sp>
           <p:nvSpPr>
-            <p:cNvPr id="23" name="Rectangle 23"/>
+            <p:cNvPr id="25" name="Rectangle 25"/>
             <p:cNvSpPr/>
             <p:nvPr/>
           </p:nvSpPr>
@@ -13868,7 +13932,7 @@
         </p:sp>
         <p:sp>
           <p:nvSpPr>
-            <p:cNvPr id="24" name="TextBox 24"/>
+            <p:cNvPr id="26" name="TextBox 26"/>
             <p:cNvSpPr txBox="1"/>
             <p:nvPr/>
           </p:nvSpPr>
@@ -13908,7 +13972,7 @@
         </p:sp>
         <p:sp>
           <p:nvSpPr>
-            <p:cNvPr id="25" name="TextBox 25"/>
+            <p:cNvPr id="27" name="TextBox 27"/>
             <p:cNvSpPr txBox="1"/>
             <p:nvPr/>
           </p:nvSpPr>
@@ -13976,7 +14040,7 @@
         </p:sp>
         <p:sp>
           <p:nvSpPr>
-            <p:cNvPr id="26" name="Rectangle 26"/>
+            <p:cNvPr id="28" name="Rectangle 28"/>
             <p:cNvSpPr/>
             <p:nvPr/>
           </p:nvSpPr>
@@ -13998,7 +14062,7 @@
         </p:sp>
         <p:sp>
           <p:nvSpPr>
-            <p:cNvPr id="27" name="TextBox 27"/>
+            <p:cNvPr id="29" name="TextBox 29"/>
             <p:cNvSpPr txBox="1"/>
             <p:nvPr/>
           </p:nvSpPr>
@@ -14038,7 +14102,7 @@
         </p:sp>
         <p:sp>
           <p:nvSpPr>
-            <p:cNvPr id="28" name="TextBox 28"/>
+            <p:cNvPr id="30" name="TextBox 30"/>
             <p:cNvSpPr txBox="1"/>
             <p:nvPr/>
           </p:nvSpPr>
@@ -14107,7 +14171,7 @@
       </p:grpSp>
       <p:grpSp>
         <p:nvGrpSpPr>
-          <p:cNvPr id="31" name="Group 31"/>
+          <p:cNvPr id="33" name="Group 33"/>
           <p:cNvGrpSpPr/>
           <p:nvPr/>
         </p:nvGrpSpPr>
@@ -14121,7 +14185,7 @@
         </p:grpSpPr>
         <p:sp>
           <p:nvSpPr>
-            <p:cNvPr id="30" name="TextBox 30"/>
+            <p:cNvPr id="32" name="TextBox 32"/>
             <p:cNvSpPr txBox="1"/>
             <p:nvPr/>
           </p:nvSpPr>
@@ -14162,7 +14226,7 @@
       </p:grpSp>
       <p:grpSp>
         <p:nvGrpSpPr>
-          <p:cNvPr id="33" name="Group 33"/>
+          <p:cNvPr id="35" name="Group 35"/>
           <p:cNvGrpSpPr/>
           <p:nvPr/>
         </p:nvGrpSpPr>
@@ -14176,7 +14240,7 @@
         </p:grpSpPr>
         <p:sp>
           <p:nvSpPr>
-            <p:cNvPr id="32" name="TextBox 32"/>
+            <p:cNvPr id="34" name="TextBox 34"/>
             <p:cNvSpPr txBox="1"/>
             <p:nvPr/>
           </p:nvSpPr>

</xml_diff>